<commit_message>
Écran classique : logo AIn7 posé sur un carré blanc
Co-Authored-By: Claude Opus 5.5 <noreply@anthropic.com>
</commit_message>
<xml_diff>
--- a/alternatives/classique/ecran-soiree.pptx
+++ b/alternatives/classique/ecran-soiree.pptx
@@ -112,24 +112,24 @@
   <p:extLst>
     <p:ext uri="{521415D9-36F7-43E2-AB2F-B90AF26B5E84}">
       <p14:sectionLst xmlns:p14="http://schemas.microsoft.com/office/powerpoint/2010/main">
-        <p14:section name="Ouverture" id="{2518B8B1-9F59-4BDE-B859-DF05D26C42B2}">
+        <p14:section name="Ouverture" id="{9A618E44-FF54-4ADC-A1F9-6D4F380FEADB}">
           <p14:sldIdLst>
             <p14:sldId id="256"/>
           </p14:sldIdLst>
         </p14:section>
-        <p14:section name="Guests" id="{8220E410-8659-4F0A-8066-654C0435DA6C}">
+        <p14:section name="Guests" id="{BCCED5A3-0EAC-4252-9DBD-FF04E4EF7C10}">
           <p14:sldIdLst>
             <p14:sldId id="257"/>
             <p14:sldId id="258"/>
             <p14:sldId id="259"/>
           </p14:sldIdLst>
         </p14:section>
-        <p14:section name="Clôture" id="{A100CC8E-59A6-474F-8A6E-BD88A9490030}">
+        <p14:section name="Clôture" id="{64340F14-029F-42AD-92D9-81C433CB642D}">
           <p14:sldIdLst>
             <p14:sldId id="260"/>
           </p14:sldIdLst>
         </p14:section>
-        <p14:section name="Secours (masqué)" id="{84E0BEAA-658B-4FD1-AF79-7B675DABA528}">
+        <p14:section name="Secours (masqué)" id="{BCABC200-FCC7-4E02-A859-EC65433AE73B}">
           <p14:sldIdLst>
             <p14:sldId id="261"/>
           </p14:sldIdLst>
@@ -875,7 +875,7 @@
           </a:p>
           <a:p>
             <a:r>
-              <a:t>Retour de Tristan (organisation) : garder cet écran, sans les cartes blanches derrière les logos. Les logos sont donc posés directement sur le fond : ceux de l’école, de N7 Développement et de La Mêlée en blanc ; Genius et AIn7 gardent leur carré de couleur, qui fait partie du logo.</a:t>
+              <a:t>Retour de Tristan (organisation) : garder cet écran, sans les cartes blanches derrière les logos. Les logos sont donc posés directement sur le fond : ceux de l’école, de N7 Développement et de La Mêlée en blanc ; Genius garde son carré doré, qui fait partie du logo ; AIn7 est posé sur un carré blanc de même taille, car son logo est dessiné pour un fond blanc (retour d’Alexis du 17/10).</a:t>
             </a:r>
           </a:p>
           <a:p>
@@ -4219,7 +4219,7 @@
       </p:sp>
       <p:pic>
         <p:nvPicPr>
-          <p:cNvPr id="10" name="Logo AIn7" descr="ain7-recadre.png"/>
+          <p:cNvPr id="10" name="Logo AIn7" descr="ain7-sur-blanc.png"/>
           <p:cNvPicPr>
             <a:picLocks noChangeAspect="1"/>
           </p:cNvPicPr>
@@ -4233,8 +4233,8 @@
         </p:blipFill>
         <p:spPr>
           <a:xfrm>
-            <a:off x="1687626" y="5074920"/>
-            <a:ext cx="556666" cy="566928"/>
+            <a:off x="1682495" y="5074920"/>
+            <a:ext cx="566928" cy="566928"/>
           </a:xfrm>
           <a:prstGeom prst="rect">
             <a:avLst/>
@@ -4917,7 +4917,7 @@
       </p:pic>
       <p:pic>
         <p:nvPicPr>
-          <p:cNvPr id="9" name="Logo AIn7" descr="ain7-recadre.png"/>
+          <p:cNvPr id="9" name="Logo AIn7" descr="ain7-sur-blanc.png"/>
           <p:cNvPicPr>
             <a:picLocks noChangeAspect="1"/>
           </p:cNvPicPr>
@@ -4931,8 +4931,8 @@
         </p:blipFill>
         <p:spPr>
           <a:xfrm>
-            <a:off x="2086445" y="2743200"/>
-            <a:ext cx="1167204" cy="1188720"/>
+            <a:off x="2075688" y="2743200"/>
+            <a:ext cx="1188720" cy="1188720"/>
           </a:xfrm>
           <a:prstGeom prst="rect">
             <a:avLst/>

</xml_diff>